<commit_message>
Update Rozendaal_Mod10_csd380.pptx with new content
</commit_message>
<xml_diff>
--- a/Module 10/Rozendaal_Mod10_csd380.pptx
+++ b/Module 10/Rozendaal_Mod10_csd380.pptx
@@ -111,6 +111,11 @@
       </a:defRPr>
     </a:lvl9pPr>
   </p:defaultTextStyle>
+  <p:extLst>
+    <p:ext uri="{EFAFB233-063F-42B5-8137-9DF3F51BA10A}">
+      <p15:sldGuideLst xmlns:p15="http://schemas.microsoft.com/office/powerpoint/2012/main"/>
+    </p:ext>
+  </p:extLst>
 </p:presentation>
 </file>
 
@@ -15229,7 +15234,7 @@
           <a:p>
             <a:fld id="{2153686A-5669-4761-B2A0-8F59B432D943}" type="datetimeFigureOut">
               <a:rPr lang="en-US" smtClean="0"/>
-              <a:t>7/14/2026</a:t>
+              <a:t>7/20/2026</a:t>
             </a:fld>
             <a:endParaRPr lang="en-US" dirty="0"/>
           </a:p>
@@ -15427,7 +15432,7 @@
           <a:p>
             <a:fld id="{2153686A-5669-4761-B2A0-8F59B432D943}" type="datetimeFigureOut">
               <a:rPr lang="en-US" smtClean="0"/>
-              <a:t>7/14/2026</a:t>
+              <a:t>7/20/2026</a:t>
             </a:fld>
             <a:endParaRPr lang="en-US" dirty="0"/>
           </a:p>
@@ -15635,7 +15640,7 @@
           <a:p>
             <a:fld id="{2153686A-5669-4761-B2A0-8F59B432D943}" type="datetimeFigureOut">
               <a:rPr lang="en-US" smtClean="0"/>
-              <a:t>7/14/2026</a:t>
+              <a:t>7/20/2026</a:t>
             </a:fld>
             <a:endParaRPr lang="en-US" dirty="0"/>
           </a:p>
@@ -15833,7 +15838,7 @@
           <a:p>
             <a:fld id="{2153686A-5669-4761-B2A0-8F59B432D943}" type="datetimeFigureOut">
               <a:rPr lang="en-US" smtClean="0"/>
-              <a:t>7/14/2026</a:t>
+              <a:t>7/20/2026</a:t>
             </a:fld>
             <a:endParaRPr lang="en-US" dirty="0"/>
           </a:p>
@@ -16108,7 +16113,7 @@
           <a:p>
             <a:fld id="{2153686A-5669-4761-B2A0-8F59B432D943}" type="datetimeFigureOut">
               <a:rPr lang="en-US" smtClean="0"/>
-              <a:t>7/14/2026</a:t>
+              <a:t>7/20/2026</a:t>
             </a:fld>
             <a:endParaRPr lang="en-US" dirty="0"/>
           </a:p>
@@ -16373,7 +16378,7 @@
           <a:p>
             <a:fld id="{2153686A-5669-4761-B2A0-8F59B432D943}" type="datetimeFigureOut">
               <a:rPr lang="en-US" smtClean="0"/>
-              <a:t>7/14/2026</a:t>
+              <a:t>7/20/2026</a:t>
             </a:fld>
             <a:endParaRPr lang="en-US" dirty="0"/>
           </a:p>
@@ -16785,7 +16790,7 @@
           <a:p>
             <a:fld id="{2153686A-5669-4761-B2A0-8F59B432D943}" type="datetimeFigureOut">
               <a:rPr lang="en-US" smtClean="0"/>
-              <a:t>7/14/2026</a:t>
+              <a:t>7/20/2026</a:t>
             </a:fld>
             <a:endParaRPr lang="en-US" dirty="0"/>
           </a:p>
@@ -16926,7 +16931,7 @@
           <a:p>
             <a:fld id="{2153686A-5669-4761-B2A0-8F59B432D943}" type="datetimeFigureOut">
               <a:rPr lang="en-US" smtClean="0"/>
-              <a:t>7/14/2026</a:t>
+              <a:t>7/20/2026</a:t>
             </a:fld>
             <a:endParaRPr lang="en-US" dirty="0"/>
           </a:p>
@@ -17039,7 +17044,7 @@
           <a:p>
             <a:fld id="{2153686A-5669-4761-B2A0-8F59B432D943}" type="datetimeFigureOut">
               <a:rPr lang="en-US" smtClean="0"/>
-              <a:t>7/14/2026</a:t>
+              <a:t>7/20/2026</a:t>
             </a:fld>
             <a:endParaRPr lang="en-US" dirty="0"/>
           </a:p>
@@ -17350,7 +17355,7 @@
           <a:p>
             <a:fld id="{2153686A-5669-4761-B2A0-8F59B432D943}" type="datetimeFigureOut">
               <a:rPr lang="en-US" smtClean="0"/>
-              <a:t>7/14/2026</a:t>
+              <a:t>7/20/2026</a:t>
             </a:fld>
             <a:endParaRPr lang="en-US" dirty="0"/>
           </a:p>
@@ -17638,7 +17643,7 @@
           <a:p>
             <a:fld id="{2153686A-5669-4761-B2A0-8F59B432D943}" type="datetimeFigureOut">
               <a:rPr lang="en-US" smtClean="0"/>
-              <a:t>7/14/2026</a:t>
+              <a:t>7/20/2026</a:t>
             </a:fld>
             <a:endParaRPr lang="en-US" dirty="0"/>
           </a:p>
@@ -17879,7 +17884,7 @@
           <a:p>
             <a:fld id="{2153686A-5669-4761-B2A0-8F59B432D943}" type="datetimeFigureOut">
               <a:rPr lang="en-US" smtClean="0"/>
-              <a:t>7/14/2026</a:t>
+              <a:t>7/20/2026</a:t>
             </a:fld>
             <a:endParaRPr lang="en-US" dirty="0"/>
           </a:p>
@@ -22733,6 +22738,36 @@
           <a:p>
             <a:r>
               <a:rPr lang="en-US" i="1" dirty="0"/>
+              <a:t>Microsoft. (2026). Microsoft Copilot [Large language model]. </a:t>
+            </a:r>
+            <a:r>
+              <a:rPr lang="en-US" i="1" dirty="0">
+                <a:hlinkClick r:id="rId2"/>
+              </a:rPr>
+              <a:t>https://copilot.microsoft.com</a:t>
+            </a:r>
+            <a:endParaRPr lang="en-US" i="1" dirty="0"/>
+          </a:p>
+          <a:p>
+            <a:r>
+              <a:rPr lang="en-US" i="1" dirty="0"/>
+              <a:t>Protecting against security threats - GitHub Docs</a:t>
+            </a:r>
+            <a:r>
+              <a:rPr lang="en-US" dirty="0"/>
+              <a:t>. (2026). GitHub Docs. </a:t>
+            </a:r>
+            <a:r>
+              <a:rPr lang="en-US">
+                <a:hlinkClick r:id="rId3"/>
+              </a:rPr>
+              <a:t>https://docs.github.com/en/code-security/tutorials/secure-your-organization/protect-against-threats</a:t>
+            </a:r>
+            <a:endParaRPr lang="en-US" i="1" dirty="0"/>
+          </a:p>
+          <a:p>
+            <a:r>
+              <a:rPr lang="en-US" i="1" dirty="0"/>
               <a:t>Repository Hardening | Security Alliance</a:t>
             </a:r>
             <a:r>
@@ -22741,14 +22776,7 @@
             </a:r>
           </a:p>
           <a:p>
-            <a:r>
-              <a:rPr lang="en-US" i="1" dirty="0"/>
-              <a:t>Protecting against security threats - GitHub Docs</a:t>
-            </a:r>
-            <a:r>
-              <a:rPr lang="en-US" dirty="0"/>
-              <a:t>. (2026). GitHub Docs. https://docs.github.com/en/code-security/tutorials/secure-your-organization/protect-against-threats</a:t>
-            </a:r>
+            <a:endParaRPr lang="en-US" dirty="0"/>
           </a:p>
         </p:txBody>
       </p:sp>

</xml_diff>